<commit_message>
Update course materials and add new K-means exercise answers
</commit_message>
<xml_diff>
--- a/第一週_1.課堂規定及評量標準.pptx
+++ b/第一週_1.課堂規定及評量標準.pptx
@@ -205,7 +205,7 @@
           <a:p>
             <a:fld id="{31A8676C-D457-4A0B-9C91-83939419494E}" type="datetimeFigureOut">
               <a:rPr lang="zh-TW" altLang="en-US" smtClean="0"/>
-              <a:t>2025/9/9</a:t>
+              <a:t>2025/12/24</a:t>
             </a:fld>
             <a:endParaRPr lang="zh-TW" altLang="en-US"/>
           </a:p>
@@ -693,7 +693,7 @@
           <a:p>
             <a:fld id="{6930F9A4-4469-4216-8732-74830AAB3356}" type="datetimeFigureOut">
               <a:rPr lang="zh-TW" altLang="en-US" smtClean="0"/>
-              <a:t>2025/9/9</a:t>
+              <a:t>2025/12/24</a:t>
             </a:fld>
             <a:endParaRPr lang="zh-TW" altLang="en-US"/>
           </a:p>
@@ -863,7 +863,7 @@
           <a:p>
             <a:fld id="{6930F9A4-4469-4216-8732-74830AAB3356}" type="datetimeFigureOut">
               <a:rPr lang="zh-TW" altLang="en-US" smtClean="0"/>
-              <a:t>2025/9/9</a:t>
+              <a:t>2025/12/24</a:t>
             </a:fld>
             <a:endParaRPr lang="zh-TW" altLang="en-US"/>
           </a:p>
@@ -1043,7 +1043,7 @@
           <a:p>
             <a:fld id="{6930F9A4-4469-4216-8732-74830AAB3356}" type="datetimeFigureOut">
               <a:rPr lang="zh-TW" altLang="en-US" smtClean="0"/>
-              <a:t>2025/9/9</a:t>
+              <a:t>2025/12/24</a:t>
             </a:fld>
             <a:endParaRPr lang="zh-TW" altLang="en-US"/>
           </a:p>
@@ -1213,7 +1213,7 @@
           <a:p>
             <a:fld id="{6930F9A4-4469-4216-8732-74830AAB3356}" type="datetimeFigureOut">
               <a:rPr lang="zh-TW" altLang="en-US" smtClean="0"/>
-              <a:t>2025/9/9</a:t>
+              <a:t>2025/12/24</a:t>
             </a:fld>
             <a:endParaRPr lang="zh-TW" altLang="en-US"/>
           </a:p>
@@ -1459,7 +1459,7 @@
           <a:p>
             <a:fld id="{6930F9A4-4469-4216-8732-74830AAB3356}" type="datetimeFigureOut">
               <a:rPr lang="zh-TW" altLang="en-US" smtClean="0"/>
-              <a:t>2025/9/9</a:t>
+              <a:t>2025/12/24</a:t>
             </a:fld>
             <a:endParaRPr lang="zh-TW" altLang="en-US"/>
           </a:p>
@@ -1691,7 +1691,7 @@
           <a:p>
             <a:fld id="{6930F9A4-4469-4216-8732-74830AAB3356}" type="datetimeFigureOut">
               <a:rPr lang="zh-TW" altLang="en-US" smtClean="0"/>
-              <a:t>2025/9/9</a:t>
+              <a:t>2025/12/24</a:t>
             </a:fld>
             <a:endParaRPr lang="zh-TW" altLang="en-US"/>
           </a:p>
@@ -2058,7 +2058,7 @@
           <a:p>
             <a:fld id="{6930F9A4-4469-4216-8732-74830AAB3356}" type="datetimeFigureOut">
               <a:rPr lang="zh-TW" altLang="en-US" smtClean="0"/>
-              <a:t>2025/9/9</a:t>
+              <a:t>2025/12/24</a:t>
             </a:fld>
             <a:endParaRPr lang="zh-TW" altLang="en-US"/>
           </a:p>
@@ -2176,7 +2176,7 @@
           <a:p>
             <a:fld id="{6930F9A4-4469-4216-8732-74830AAB3356}" type="datetimeFigureOut">
               <a:rPr lang="zh-TW" altLang="en-US" smtClean="0"/>
-              <a:t>2025/9/9</a:t>
+              <a:t>2025/12/24</a:t>
             </a:fld>
             <a:endParaRPr lang="zh-TW" altLang="en-US"/>
           </a:p>
@@ -2271,7 +2271,7 @@
           <a:p>
             <a:fld id="{6930F9A4-4469-4216-8732-74830AAB3356}" type="datetimeFigureOut">
               <a:rPr lang="zh-TW" altLang="en-US" smtClean="0"/>
-              <a:t>2025/9/9</a:t>
+              <a:t>2025/12/24</a:t>
             </a:fld>
             <a:endParaRPr lang="zh-TW" altLang="en-US"/>
           </a:p>
@@ -2548,7 +2548,7 @@
           <a:p>
             <a:fld id="{6930F9A4-4469-4216-8732-74830AAB3356}" type="datetimeFigureOut">
               <a:rPr lang="zh-TW" altLang="en-US" smtClean="0"/>
-              <a:t>2025/9/9</a:t>
+              <a:t>2025/12/24</a:t>
             </a:fld>
             <a:endParaRPr lang="zh-TW" altLang="en-US"/>
           </a:p>
@@ -2801,7 +2801,7 @@
           <a:p>
             <a:fld id="{6930F9A4-4469-4216-8732-74830AAB3356}" type="datetimeFigureOut">
               <a:rPr lang="zh-TW" altLang="en-US" smtClean="0"/>
-              <a:t>2025/9/9</a:t>
+              <a:t>2025/12/24</a:t>
             </a:fld>
             <a:endParaRPr lang="zh-TW" altLang="en-US"/>
           </a:p>
@@ -3014,7 +3014,7 @@
           <a:p>
             <a:fld id="{6930F9A4-4469-4216-8732-74830AAB3356}" type="datetimeFigureOut">
               <a:rPr lang="zh-TW" altLang="en-US" smtClean="0"/>
-              <a:t>2025/9/9</a:t>
+              <a:t>2025/12/24</a:t>
             </a:fld>
             <a:endParaRPr lang="zh-TW" altLang="en-US"/>
           </a:p>
@@ -8405,35 +8405,35 @@
           <a:p>
             <a:pPr algn="ctr"/>
             <a:r>
-              <a:rPr lang="zh-TW" altLang="en-US" sz="2000" dirty="0">
+              <a:rPr lang="zh-TW" altLang="en-US" sz="2000" strike="dblStrike" dirty="0">
                 <a:latin typeface="標楷體" panose="03000509000000000000" pitchFamily="65" charset="-120"/>
                 <a:ea typeface="標楷體" panose="03000509000000000000" pitchFamily="65" charset="-120"/>
               </a:rPr>
               <a:t>報告後</a:t>
             </a:r>
             <a:r>
-              <a:rPr lang="en-US" altLang="zh-TW" sz="2000" dirty="0">
+              <a:rPr lang="en-US" altLang="zh-TW" sz="2000" strike="dblStrike" dirty="0">
                 <a:latin typeface="標楷體" panose="03000509000000000000" pitchFamily="65" charset="-120"/>
                 <a:ea typeface="標楷體" panose="03000509000000000000" pitchFamily="65" charset="-120"/>
               </a:rPr>
               <a:t>, </a:t>
             </a:r>
             <a:r>
-              <a:rPr lang="zh-TW" altLang="en-US" sz="2000" dirty="0">
+              <a:rPr lang="zh-TW" altLang="en-US" sz="2000" strike="dblStrike" dirty="0">
                 <a:latin typeface="標楷體" panose="03000509000000000000" pitchFamily="65" charset="-120"/>
                 <a:ea typeface="標楷體" panose="03000509000000000000" pitchFamily="65" charset="-120"/>
               </a:rPr>
               <a:t>將你的</a:t>
             </a:r>
             <a:r>
-              <a:rPr lang="en-US" altLang="zh-TW" sz="2000" dirty="0">
+              <a:rPr lang="en-US" altLang="zh-TW" sz="2000" strike="dblStrike" dirty="0">
                 <a:latin typeface="標楷體" panose="03000509000000000000" pitchFamily="65" charset="-120"/>
                 <a:ea typeface="標楷體" panose="03000509000000000000" pitchFamily="65" charset="-120"/>
               </a:rPr>
               <a:t>PPT LINE</a:t>
             </a:r>
             <a:r>
-              <a:rPr lang="zh-TW" altLang="en-US" sz="2000" dirty="0">
+              <a:rPr lang="zh-TW" altLang="en-US" sz="2000" strike="dblStrike" dirty="0">
                 <a:latin typeface="標楷體" panose="03000509000000000000" pitchFamily="65" charset="-120"/>
                 <a:ea typeface="標楷體" panose="03000509000000000000" pitchFamily="65" charset="-120"/>
               </a:rPr>

</xml_diff>